<commit_message>
Fig. 2: remove RDA indicators from step labels and speaker notes (mapping now in Suppl. Table S2 only)
Co-Authored-By: Claude Opus 5.5 <noreply@anthropic.com>
</commit_message>
<xml_diff>
--- a/figures/fig2_fair_levels/fig2_fair_levels_design.pptx
+++ b/figures/fig2_fair_levels/fig2_fair_levels_design.pptx
@@ -503,47 +503,25 @@
             <a:r>
               <a:rPr lang="en-US" dirty="0"/>
               <a:t>Fig. 2 design draft: levels of FAIRness and the layers that enable them. Steps follow the visual style and layer numbers (1-6) of Fig. 1. Steps are linked to layers by colour and number badge rather than connector lines (TODO F7).
-EXPLICIT MAPPING (check with a FAIR expert, TODO C6). FAIR principles: Wilkinson et al. 2016, Sci Data 3:160018. RDA indicators: RDA FAIR Data Maturity Model v1.0 (doi:10.15497/rda00050); IDs shown in the figure without the 'RDA-' prefix; RDA priority in brackets. Many indicators depend on several layers; Suppl. Table S2 lists all contributions. F2 and R1.2 are met jointly by levels 2-3 (content) and level 5 (exposure).
+FAIR PRINCIPLES PER LEVEL (Wilkinson et al. 2016, Sci Data 3:160018). The mapping to the RDA FAIR Data Maturity Model indicators is in Suppl. Table S2 only.
 LEVEL 0, OPAQUE (NO STANDARD)
 FAIR principles: none
-RDA indicators: none
 LEVEL 1, READABLE (5 DATA FORMATS)
 FAIR principles:
   I1: (Meta)data use a formal, accessible, shared, and broadly applicable language for knowledge representation.
-RDA indicators:
-  RDA-I1-01D: Data uses knowledge representation expressed in standardised format [important]
 LEVEL 2, INTERPRETABLE FILES (3 FILE ORGANIZATION STANDARDS)
 FAIR principles:
   R1: (Meta)data are richly described with a plurality of accurate and relevant attributes.
   R1.3: (Meta)data meet domain-relevant community standards.
-RDA indicators:
-  RDA-R1.3-01D: Data complies with a community standard [essential]
-  RDA-R1.3-02D: Data is expressed in compliance with a machine-understandable community standard [important]
-  RDA-I1-02D: Data uses machine-understandable knowledge representation [important]
 LEVEL 3, ORGANIZED DATASET (2 DATASET ORGANIZATION STANDARDS)
 FAIR principles:
   R1: (Meta)data are richly described with a plurality of accurate and relevant attributes.
   R1.3: (Meta)data meet domain-relevant community standards.
   F2: Data are described with rich metadata (defined by R1).
-RDA indicators:
-  RDA-R1.3-01M: Metadata complies with a community standard [essential]
-  RDA-R1.3-02M: Metadata is expressed in compliance with a machine-understandable community standard [essential]
-  RDA-I1-01M: Metadata uses knowledge representation expressed in standardised format [important]
-  RDA-I1-02M: Metadata uses machine-understandable knowledge representation [important]
-  RDA-R1-01M: Plurality of accurate and relevant attributes are provided to allow reuse [essential]
 LEVEL 4, INTEROPERABLE (4 ONTOLOGIES &amp; TERMINOLOGIES)
 FAIR principles:
   I2: (Meta)data use vocabularies that follow FAIR principles.
   I3: (Meta)data include qualified references to other (meta)data.
-RDA indicators:
-  RDA-I2-01M: Metadata uses FAIR-compliant vocabularies [important]
-  RDA-I2-01D: Data uses FAIR-compliant vocabularies [useful]
-  RDA-I3-01M: Metadata includes references to other metadata [important]
-  RDA-I3-02M: Metadata includes references to other data [useful]
-  RDA-I3-03M: Metadata includes qualified references to other metadata [important]
-  RDA-I3-04M: Metadata include qualified references to other data [useful]
-  RDA-I3-01D: Data includes references to other data [useful]
-  RDA-I3-02D: Data includes qualified references to other data [useful]
 LEVEL 5, FINDABLE AND REUSABLE RECORD (1 DATA ARCHIVES)
 FAIR principles:
   F1: (Meta)data are assigned a globally unique and persistent identifier.
@@ -555,32 +533,7 @@
   A1.2: The protocol allows for an authentication and authorisation procedure, where necessary.
   A2: Metadata are accessible, even when the data are no longer available.
   R1.1: (Meta)data are released with a clear and accessible data usage licence.
-  R1.2: (Meta)data are associated with detailed provenance.
-RDA indicators:
-  RDA-F1-01M: Metadata is identified by a persistent identifier [essential]
-  RDA-F1-01D: Data is identified by a persistent identifier [essential]
-  RDA-F1-02M: Metadata is identified by a globally unique identifier [essential]
-  RDA-F1-02D: Data is identified by a globally unique identifier [essential]
-  RDA-F2-01M: Rich metadata is provided to allow discovery [essential]
-  RDA-F3-01M: Metadata includes the identifier for the data [essential]
-  RDA-F4-01M: Metadata is offered in such a way that it can be harvested and indexed [essential]
-  RDA-A1-01M: Metadata contains information to enable the user to get access to the data [important]
-  RDA-A1-02M: Metadata can be accessed manually (i.e. with human intervention) [essential]
-  RDA-A1-02D: Data can be accessed manually (i.e. with human intervention) [essential]
-  RDA-A1-03M: Metadata identifier resolves to a metadata record [essential]
-  RDA-A1-03D: Data identifier resolves to a digital object [essential]
-  RDA-A1-04M: Metadata is accessed through standardised protocol [essential]
-  RDA-A1-04D: Data is accessible through standardised protocol [essential]
-  RDA-A1-05D: Data can be accessed automatically (i.e. by a computer program) [important]
-  RDA-A1.1-01M: Metadata is accessible through a free access protocol [essential]
-  RDA-A1.1-01D: Data is accessible through a free access protocol [important]
-  RDA-A1.2-01D: Data is accessible through an access protocol that supports authentication and authorisation [useful]
-  RDA-A2-01M: Metadata is guaranteed to remain available after data is no longer available [essential]
-  RDA-R1.1-01M: Metadata includes information about the licence under which the data can be reused [essential]
-  RDA-R1.1-02M: Metadata refers to a standard reuse licence [important]
-  RDA-R1.1-03M: Metadata refers to a machine-understandable reuse licence [important]
-  RDA-R1.2-01M: Metadata includes provenance information according to community-specific standards [important]
-  RDA-R1.2-02M: Metadata includes provenance information according to a cross-domain language [useful]</a:t>
+  R1.2: (Meta)data are associated with detailed provenance.</a:t>
             </a:r>
             <a:endParaRPr lang="en-US" dirty="0"/>
           </a:p>
@@ -1091,8 +1044,8 @@
         </p:nvSpPr>
         <p:spPr>
           <a:xfrm>
-            <a:off x="475488" y="4462272"/>
-            <a:ext cx="1764792" cy="1133856"/>
+            <a:off x="475488" y="4754880"/>
+            <a:ext cx="1764792" cy="841248"/>
           </a:xfrm>
           <a:prstGeom prst="rect">
             <a:avLst/>
@@ -1151,37 +1104,6 @@
                 <a:cs typeface="Arial" pitchFamily="34" charset="-120"/>
               </a:rPr>
               <a:t>FAIR: </a:t>
-            </a:r>
-            <a:pPr indent="0" marL="0">
-              <a:buNone/>
-            </a:pPr>
-            <a:r>
-              <a:rPr lang="en-US" sz="900" dirty="0">
-                <a:solidFill>
-                  <a:srgbClr val="1F2933"/>
-                </a:solidFill>
-                <a:latin typeface="Arial" pitchFamily="34" charset="0"/>
-                <a:ea typeface="Arial" pitchFamily="34" charset="-122"/>
-                <a:cs typeface="Arial" pitchFamily="34" charset="-120"/>
-              </a:rPr>
-              <a:t>none</a:t>
-            </a:r>
-            <a:endParaRPr lang="en-US" sz="950" dirty="0"/>
-          </a:p>
-          <a:p>
-            <a:pPr indent="0" marL="0">
-              <a:buNone/>
-            </a:pPr>
-            <a:r>
-              <a:rPr lang="en-US" sz="900" dirty="0">
-                <a:solidFill>
-                  <a:srgbClr val="5B6770"/>
-                </a:solidFill>
-                <a:latin typeface="Arial" pitchFamily="34" charset="0"/>
-                <a:ea typeface="Arial" pitchFamily="34" charset="-122"/>
-                <a:cs typeface="Arial" pitchFamily="34" charset="-120"/>
-              </a:rPr>
-              <a:t>RDA: </a:t>
             </a:r>
             <a:pPr indent="0" marL="0">
               <a:buNone/>
@@ -1403,8 +1325,8 @@
         </p:nvSpPr>
         <p:spPr>
           <a:xfrm>
-            <a:off x="2368296" y="3749040"/>
-            <a:ext cx="1764792" cy="1133856"/>
+            <a:off x="2368296" y="4041648"/>
+            <a:ext cx="1764792" cy="841248"/>
           </a:xfrm>
           <a:prstGeom prst="rect">
             <a:avLst/>
@@ -1477,37 +1399,6 @@
                 <a:cs typeface="Arial" pitchFamily="34" charset="-120"/>
               </a:rPr>
               <a:t>I1</a:t>
-            </a:r>
-            <a:endParaRPr lang="en-US" sz="950" dirty="0"/>
-          </a:p>
-          <a:p>
-            <a:pPr indent="0" marL="0">
-              <a:buNone/>
-            </a:pPr>
-            <a:r>
-              <a:rPr lang="en-US" sz="900" dirty="0">
-                <a:solidFill>
-                  <a:srgbClr val="5B6770"/>
-                </a:solidFill>
-                <a:latin typeface="Arial" pitchFamily="34" charset="0"/>
-                <a:ea typeface="Arial" pitchFamily="34" charset="-122"/>
-                <a:cs typeface="Arial" pitchFamily="34" charset="-120"/>
-              </a:rPr>
-              <a:t>RDA: </a:t>
-            </a:r>
-            <a:pPr indent="0" marL="0">
-              <a:buNone/>
-            </a:pPr>
-            <a:r>
-              <a:rPr lang="en-US" sz="900" dirty="0">
-                <a:solidFill>
-                  <a:srgbClr val="1F2933"/>
-                </a:solidFill>
-                <a:latin typeface="Arial" pitchFamily="34" charset="0"/>
-                <a:ea typeface="Arial" pitchFamily="34" charset="-122"/>
-                <a:cs typeface="Arial" pitchFamily="34" charset="-120"/>
-              </a:rPr>
-              <a:t>I1-01D</a:t>
             </a:r>
             <a:endParaRPr lang="en-US" sz="950" dirty="0"/>
           </a:p>
@@ -1715,8 +1606,8 @@
         </p:nvSpPr>
         <p:spPr>
           <a:xfrm>
-            <a:off x="4261104" y="3035808"/>
-            <a:ext cx="1764792" cy="1133856"/>
+            <a:off x="4261104" y="3328416"/>
+            <a:ext cx="1764792" cy="841248"/>
           </a:xfrm>
           <a:prstGeom prst="rect">
             <a:avLst/>
@@ -1789,54 +1680,6 @@
                 <a:cs typeface="Arial" pitchFamily="34" charset="-120"/>
               </a:rPr>
               <a:t>R1, R1.3</a:t>
-            </a:r>
-            <a:endParaRPr lang="en-US" sz="950" dirty="0"/>
-          </a:p>
-          <a:p>
-            <a:pPr indent="0" marL="0">
-              <a:buNone/>
-            </a:pPr>
-            <a:r>
-              <a:rPr lang="en-US" sz="900" dirty="0">
-                <a:solidFill>
-                  <a:srgbClr val="5B6770"/>
-                </a:solidFill>
-                <a:latin typeface="Arial" pitchFamily="34" charset="0"/>
-                <a:ea typeface="Arial" pitchFamily="34" charset="-122"/>
-                <a:cs typeface="Arial" pitchFamily="34" charset="-120"/>
-              </a:rPr>
-              <a:t>RDA: </a:t>
-            </a:r>
-            <a:pPr indent="0" marL="0">
-              <a:buNone/>
-            </a:pPr>
-            <a:r>
-              <a:rPr lang="en-US" sz="900" dirty="0">
-                <a:solidFill>
-                  <a:srgbClr val="1F2933"/>
-                </a:solidFill>
-                <a:latin typeface="Arial" pitchFamily="34" charset="0"/>
-                <a:ea typeface="Arial" pitchFamily="34" charset="-122"/>
-                <a:cs typeface="Arial" pitchFamily="34" charset="-120"/>
-              </a:rPr>
-              <a:t>R1.3-01D, R1.3-02D,</a:t>
-            </a:r>
-            <a:endParaRPr lang="en-US" sz="950" dirty="0"/>
-          </a:p>
-          <a:p>
-            <a:pPr indent="0" marL="0">
-              <a:buNone/>
-            </a:pPr>
-            <a:r>
-              <a:rPr lang="en-US" sz="900" dirty="0">
-                <a:solidFill>
-                  <a:srgbClr val="1F2933"/>
-                </a:solidFill>
-                <a:latin typeface="Arial" pitchFamily="34" charset="0"/>
-                <a:ea typeface="Arial" pitchFamily="34" charset="-122"/>
-                <a:cs typeface="Arial" pitchFamily="34" charset="-120"/>
-              </a:rPr>
-              <a:t>I1-02D</a:t>
             </a:r>
             <a:endParaRPr lang="en-US" sz="950" dirty="0"/>
           </a:p>
@@ -2044,8 +1887,8 @@
         </p:nvSpPr>
         <p:spPr>
           <a:xfrm>
-            <a:off x="6153912" y="2322576"/>
-            <a:ext cx="1764792" cy="1133856"/>
+            <a:off x="6153912" y="2615184"/>
+            <a:ext cx="1764792" cy="841248"/>
           </a:xfrm>
           <a:prstGeom prst="rect">
             <a:avLst/>
@@ -2118,54 +1961,6 @@
                 <a:cs typeface="Arial" pitchFamily="34" charset="-120"/>
               </a:rPr>
               <a:t>R1, R1.3, F2</a:t>
-            </a:r>
-            <a:endParaRPr lang="en-US" sz="950" dirty="0"/>
-          </a:p>
-          <a:p>
-            <a:pPr indent="0" marL="0">
-              <a:buNone/>
-            </a:pPr>
-            <a:r>
-              <a:rPr lang="en-US" sz="900" dirty="0">
-                <a:solidFill>
-                  <a:srgbClr val="5B6770"/>
-                </a:solidFill>
-                <a:latin typeface="Arial" pitchFamily="34" charset="0"/>
-                <a:ea typeface="Arial" pitchFamily="34" charset="-122"/>
-                <a:cs typeface="Arial" pitchFamily="34" charset="-120"/>
-              </a:rPr>
-              <a:t>RDA: </a:t>
-            </a:r>
-            <a:pPr indent="0" marL="0">
-              <a:buNone/>
-            </a:pPr>
-            <a:r>
-              <a:rPr lang="en-US" sz="900" dirty="0">
-                <a:solidFill>
-                  <a:srgbClr val="1F2933"/>
-                </a:solidFill>
-                <a:latin typeface="Arial" pitchFamily="34" charset="0"/>
-                <a:ea typeface="Arial" pitchFamily="34" charset="-122"/>
-                <a:cs typeface="Arial" pitchFamily="34" charset="-120"/>
-              </a:rPr>
-              <a:t>R1.3-01M/02M,</a:t>
-            </a:r>
-            <a:endParaRPr lang="en-US" sz="950" dirty="0"/>
-          </a:p>
-          <a:p>
-            <a:pPr indent="0" marL="0">
-              <a:buNone/>
-            </a:pPr>
-            <a:r>
-              <a:rPr lang="en-US" sz="900" dirty="0">
-                <a:solidFill>
-                  <a:srgbClr val="1F2933"/>
-                </a:solidFill>
-                <a:latin typeface="Arial" pitchFamily="34" charset="0"/>
-                <a:ea typeface="Arial" pitchFamily="34" charset="-122"/>
-                <a:cs typeface="Arial" pitchFamily="34" charset="-120"/>
-              </a:rPr>
-              <a:t>I1-01M/02M, R1-01M</a:t>
             </a:r>
             <a:endParaRPr lang="en-US" sz="950" dirty="0"/>
           </a:p>
@@ -2373,8 +2168,8 @@
         </p:nvSpPr>
         <p:spPr>
           <a:xfrm>
-            <a:off x="8046720" y="1609344"/>
-            <a:ext cx="1764792" cy="1133856"/>
+            <a:off x="8046720" y="1901952"/>
+            <a:ext cx="1764792" cy="841248"/>
           </a:xfrm>
           <a:prstGeom prst="rect">
             <a:avLst/>
@@ -2447,54 +2242,6 @@
                 <a:cs typeface="Arial" pitchFamily="34" charset="-120"/>
               </a:rPr>
               <a:t>I2, I3</a:t>
-            </a:r>
-            <a:endParaRPr lang="en-US" sz="950" dirty="0"/>
-          </a:p>
-          <a:p>
-            <a:pPr indent="0" marL="0">
-              <a:buNone/>
-            </a:pPr>
-            <a:r>
-              <a:rPr lang="en-US" sz="900" dirty="0">
-                <a:solidFill>
-                  <a:srgbClr val="5B6770"/>
-                </a:solidFill>
-                <a:latin typeface="Arial" pitchFamily="34" charset="0"/>
-                <a:ea typeface="Arial" pitchFamily="34" charset="-122"/>
-                <a:cs typeface="Arial" pitchFamily="34" charset="-120"/>
-              </a:rPr>
-              <a:t>RDA: </a:t>
-            </a:r>
-            <a:pPr indent="0" marL="0">
-              <a:buNone/>
-            </a:pPr>
-            <a:r>
-              <a:rPr lang="en-US" sz="900" dirty="0">
-                <a:solidFill>
-                  <a:srgbClr val="1F2933"/>
-                </a:solidFill>
-                <a:latin typeface="Arial" pitchFamily="34" charset="0"/>
-                <a:ea typeface="Arial" pitchFamily="34" charset="-122"/>
-                <a:cs typeface="Arial" pitchFamily="34" charset="-120"/>
-              </a:rPr>
-              <a:t>I2-01M/D, I3-01M to 04M,</a:t>
-            </a:r>
-            <a:endParaRPr lang="en-US" sz="950" dirty="0"/>
-          </a:p>
-          <a:p>
-            <a:pPr indent="0" marL="0">
-              <a:buNone/>
-            </a:pPr>
-            <a:r>
-              <a:rPr lang="en-US" sz="900" dirty="0">
-                <a:solidFill>
-                  <a:srgbClr val="1F2933"/>
-                </a:solidFill>
-                <a:latin typeface="Arial" pitchFamily="34" charset="0"/>
-                <a:ea typeface="Arial" pitchFamily="34" charset="-122"/>
-                <a:cs typeface="Arial" pitchFamily="34" charset="-120"/>
-              </a:rPr>
-              <a:t>I3-01D/02D</a:t>
             </a:r>
             <a:endParaRPr lang="en-US" sz="950" dirty="0"/>
           </a:p>
@@ -2702,8 +2449,8 @@
         </p:nvSpPr>
         <p:spPr>
           <a:xfrm>
-            <a:off x="9939528" y="896112"/>
-            <a:ext cx="1764792" cy="1133856"/>
+            <a:off x="9939528" y="1188720"/>
+            <a:ext cx="1764792" cy="841248"/>
           </a:xfrm>
           <a:prstGeom prst="rect">
             <a:avLst/>
@@ -2776,37 +2523,6 @@
                 <a:cs typeface="Arial" pitchFamily="34" charset="-120"/>
               </a:rPr>
               <a:t>F1–F4, A1–A2, R1.1, R1.2</a:t>
-            </a:r>
-            <a:endParaRPr lang="en-US" sz="950" dirty="0"/>
-          </a:p>
-          <a:p>
-            <a:pPr indent="0" marL="0">
-              <a:buNone/>
-            </a:pPr>
-            <a:r>
-              <a:rPr lang="en-US" sz="900" dirty="0">
-                <a:solidFill>
-                  <a:srgbClr val="5B6770"/>
-                </a:solidFill>
-                <a:latin typeface="Arial" pitchFamily="34" charset="0"/>
-                <a:ea typeface="Arial" pitchFamily="34" charset="-122"/>
-                <a:cs typeface="Arial" pitchFamily="34" charset="-120"/>
-              </a:rPr>
-              <a:t>RDA: </a:t>
-            </a:r>
-            <a:pPr indent="0" marL="0">
-              <a:buNone/>
-            </a:pPr>
-            <a:r>
-              <a:rPr lang="en-US" sz="900" dirty="0">
-                <a:solidFill>
-                  <a:srgbClr val="1F2933"/>
-                </a:solidFill>
-                <a:latin typeface="Arial" pitchFamily="34" charset="0"/>
-                <a:ea typeface="Arial" pitchFamily="34" charset="-122"/>
-                <a:cs typeface="Arial" pitchFamily="34" charset="-120"/>
-              </a:rPr>
-              <a:t>all F, A, R1.1, R1.2 indicators</a:t>
             </a:r>
             <a:endParaRPr lang="en-US" sz="950" dirty="0"/>
           </a:p>
@@ -3120,7 +2836,7 @@
                 <a:ea typeface="Arial" pitchFamily="34" charset="-122"/>
                 <a:cs typeface="Arial" pitchFamily="34" charset="-120"/>
               </a:rPr>
-              <a:t>Numbers 1–6 are the layers of Fig. 1 and Table 1. FAIR = FAIR principles mainly addressed; RDA = main RDA FAIR Data Maturity Model indicators (prefix omitted; M metadata, D data). Definitions in the speaker notes; full mapping in Table 2 and Suppl. Table S2.</a:t>
+              <a:t>Numbers 1–6 are the layers of Fig. 1 and Table 1. FAIR = FAIR principles mainly addressed (full text in the speaker notes).</a:t>
             </a:r>
             <a:endParaRPr lang="en-US" sz="900" dirty="0"/>
           </a:p>

</xml_diff>

<commit_message>
Update figure 1 and 2
</commit_message>
<xml_diff>
--- a/figures/fig2_fair_levels/fig2_fair_levels_design.pptx
+++ b/figures/fig2_fair_levels/fig2_fair_levels_design.pptx
@@ -2553,7 +2553,18 @@
                 <a:ea typeface="Arial" pitchFamily="34" charset="-122"/>
                 <a:cs typeface="Arial" pitchFamily="34" charset="-120"/>
               </a:rPr>
-              <a:t>Schema languages: levels 2 and 3 machine-checkable</a:t>
+              <a:t>Schema languages: </a:t>
+            </a:r>
+            <a:r>
+              <a:rPr lang="en-US" sz="1200" dirty="0">
+                <a:solidFill>
+                  <a:srgbClr val="1F2933"/>
+                </a:solidFill>
+                <a:latin typeface="Arial" pitchFamily="34" charset="0"/>
+                <a:ea typeface="Arial" pitchFamily="34" charset="-122"/>
+                <a:cs typeface="Arial" pitchFamily="34" charset="-120"/>
+              </a:rPr>
+              <a:t>ensure file and dataset organization are machine-checkable</a:t>
             </a:r>
             <a:endParaRPr lang="en-US" sz="1200" dirty="0"/>
           </a:p>

</xml_diff>